<commit_message>
docs: improve UI codebase with Vietnamese documentation and updated performance metrics
</commit_message>
<xml_diff>
--- a/slides/slides.pptx
+++ b/slides/slides.pptx
@@ -5,26 +5,26 @@
     <p:sldMasterId id="2147483648" r:id="rId1"/>
   </p:sldMasterIdLst>
   <p:sldIdLst>
-    <p:sldId id="256" r:id="rId7"/>
-    <p:sldId id="257" r:id="rId8"/>
-    <p:sldId id="258" r:id="rId9"/>
-    <p:sldId id="259" r:id="rId10"/>
-    <p:sldId id="260" r:id="rId11"/>
-    <p:sldId id="261" r:id="rId12"/>
-    <p:sldId id="262" r:id="rId13"/>
-    <p:sldId id="263" r:id="rId14"/>
-    <p:sldId id="264" r:id="rId15"/>
-    <p:sldId id="265" r:id="rId16"/>
-    <p:sldId id="266" r:id="rId17"/>
-    <p:sldId id="267" r:id="rId18"/>
-    <p:sldId id="268" r:id="rId19"/>
-    <p:sldId id="269" r:id="rId20"/>
-    <p:sldId id="270" r:id="rId21"/>
-    <p:sldId id="271" r:id="rId22"/>
-    <p:sldId id="272" r:id="rId23"/>
-    <p:sldId id="273" r:id="rId24"/>
+    <p:sldId id="256" r:id="rId2"/>
+    <p:sldId id="257" r:id="rId3"/>
+    <p:sldId id="258" r:id="rId4"/>
+    <p:sldId id="259" r:id="rId5"/>
+    <p:sldId id="260" r:id="rId6"/>
+    <p:sldId id="261" r:id="rId7"/>
+    <p:sldId id="262" r:id="rId8"/>
+    <p:sldId id="263" r:id="rId9"/>
+    <p:sldId id="264" r:id="rId10"/>
+    <p:sldId id="265" r:id="rId11"/>
+    <p:sldId id="266" r:id="rId12"/>
+    <p:sldId id="267" r:id="rId13"/>
+    <p:sldId id="268" r:id="rId14"/>
+    <p:sldId id="269" r:id="rId15"/>
+    <p:sldId id="270" r:id="rId16"/>
+    <p:sldId id="271" r:id="rId17"/>
+    <p:sldId id="272" r:id="rId18"/>
+    <p:sldId id="273" r:id="rId19"/>
   </p:sldIdLst>
-  <p:sldSz cx="12191695" cy="6858000" type="screen4x3"/>
+  <p:sldSz cx="12192000" cy="6858000"/>
   <p:notesSz cx="6858000" cy="9144000"/>
   <p:defaultTextStyle>
     <a:defPPr>
@@ -121,6 +121,22 @@
       </a:defRPr>
     </a:lvl9pPr>
   </p:defaultTextStyle>
+  <p:extLst>
+    <p:ext uri="{EFAFB233-063F-42B5-8137-9DF3F51BA10A}">
+      <p15:sldGuideLst xmlns:p15="http://schemas.microsoft.com/office/powerpoint/2012/main">
+        <p15:guide id="1" orient="horz" pos="2160">
+          <p15:clr>
+            <a:srgbClr val="A4A3A4"/>
+          </p15:clr>
+        </p15:guide>
+        <p15:guide id="2" pos="2880">
+          <p15:clr>
+            <a:srgbClr val="A4A3A4"/>
+          </p15:clr>
+        </p15:guide>
+      </p15:sldGuideLst>
+    </p:ext>
+  </p:extLst>
 </p:presentation>
 </file>
 
@@ -162,10 +178,9 @@
           <a:lstStyle/>
           <a:p>
             <a:r>
-              <a:rPr lang="en-US" smtClean="0"/>
+              <a:rPr lang="en-US"/>
               <a:t>Click to edit Master title style</a:t>
             </a:r>
-            <a:endParaRPr lang="en-US"/>
           </a:p>
         </p:txBody>
       </p:sp>
@@ -281,10 +296,9 @@
           </a:lstStyle>
           <a:p>
             <a:r>
-              <a:rPr lang="en-US" smtClean="0"/>
+              <a:rPr lang="en-US"/>
               <a:t>Click to edit Master subtitle style</a:t>
             </a:r>
-            <a:endParaRPr lang="en-US"/>
           </a:p>
         </p:txBody>
       </p:sp>
@@ -305,7 +319,7 @@
           <a:p>
             <a:fld id="{5BCAD085-E8A6-8845-BD4E-CB4CCA059FC4}" type="datetimeFigureOut">
               <a:rPr lang="en-US" smtClean="0"/>
-              <a:t>1/27/13</a:t>
+              <a:t>7/9/26</a:t>
             </a:fld>
             <a:endParaRPr lang="en-US"/>
           </a:p>
@@ -399,10 +413,9 @@
           <a:lstStyle/>
           <a:p>
             <a:r>
-              <a:rPr lang="en-US" smtClean="0"/>
+              <a:rPr lang="en-US"/>
               <a:t>Click to edit Master title style</a:t>
             </a:r>
-            <a:endParaRPr lang="en-US"/>
           </a:p>
         </p:txBody>
       </p:sp>
@@ -423,38 +436,37 @@
           <a:p>
             <a:pPr lvl="0"/>
             <a:r>
-              <a:rPr lang="en-US" smtClean="0"/>
+              <a:rPr lang="en-US"/>
               <a:t>Click to edit Master text styles</a:t>
             </a:r>
           </a:p>
           <a:p>
             <a:pPr lvl="1"/>
             <a:r>
-              <a:rPr lang="en-US" smtClean="0"/>
+              <a:rPr lang="en-US"/>
               <a:t>Second level</a:t>
             </a:r>
           </a:p>
           <a:p>
             <a:pPr lvl="2"/>
             <a:r>
-              <a:rPr lang="en-US" smtClean="0"/>
+              <a:rPr lang="en-US"/>
               <a:t>Third level</a:t>
             </a:r>
           </a:p>
           <a:p>
             <a:pPr lvl="3"/>
             <a:r>
-              <a:rPr lang="en-US" smtClean="0"/>
+              <a:rPr lang="en-US"/>
               <a:t>Fourth level</a:t>
             </a:r>
           </a:p>
           <a:p>
             <a:pPr lvl="4"/>
             <a:r>
-              <a:rPr lang="en-US" smtClean="0"/>
+              <a:rPr lang="en-US"/>
               <a:t>Fifth level</a:t>
             </a:r>
-            <a:endParaRPr lang="en-US"/>
           </a:p>
         </p:txBody>
       </p:sp>
@@ -475,7 +487,7 @@
           <a:p>
             <a:fld id="{5BCAD085-E8A6-8845-BD4E-CB4CCA059FC4}" type="datetimeFigureOut">
               <a:rPr lang="en-US" smtClean="0"/>
-              <a:t>1/27/13</a:t>
+              <a:t>7/9/26</a:t>
             </a:fld>
             <a:endParaRPr lang="en-US"/>
           </a:p>
@@ -574,10 +586,9 @@
           <a:lstStyle/>
           <a:p>
             <a:r>
-              <a:rPr lang="en-US" smtClean="0"/>
+              <a:rPr lang="en-US"/>
               <a:t>Click to edit Master title style</a:t>
             </a:r>
-            <a:endParaRPr lang="en-US"/>
           </a:p>
         </p:txBody>
       </p:sp>
@@ -603,38 +614,37 @@
           <a:p>
             <a:pPr lvl="0"/>
             <a:r>
-              <a:rPr lang="en-US" smtClean="0"/>
+              <a:rPr lang="en-US"/>
               <a:t>Click to edit Master text styles</a:t>
             </a:r>
           </a:p>
           <a:p>
             <a:pPr lvl="1"/>
             <a:r>
-              <a:rPr lang="en-US" smtClean="0"/>
+              <a:rPr lang="en-US"/>
               <a:t>Second level</a:t>
             </a:r>
           </a:p>
           <a:p>
             <a:pPr lvl="2"/>
             <a:r>
-              <a:rPr lang="en-US" smtClean="0"/>
+              <a:rPr lang="en-US"/>
               <a:t>Third level</a:t>
             </a:r>
           </a:p>
           <a:p>
             <a:pPr lvl="3"/>
             <a:r>
-              <a:rPr lang="en-US" smtClean="0"/>
+              <a:rPr lang="en-US"/>
               <a:t>Fourth level</a:t>
             </a:r>
           </a:p>
           <a:p>
             <a:pPr lvl="4"/>
             <a:r>
-              <a:rPr lang="en-US" smtClean="0"/>
+              <a:rPr lang="en-US"/>
               <a:t>Fifth level</a:t>
             </a:r>
-            <a:endParaRPr lang="en-US"/>
           </a:p>
         </p:txBody>
       </p:sp>
@@ -655,7 +665,7 @@
           <a:p>
             <a:fld id="{5BCAD085-E8A6-8845-BD4E-CB4CCA059FC4}" type="datetimeFigureOut">
               <a:rPr lang="en-US" smtClean="0"/>
-              <a:t>1/27/13</a:t>
+              <a:t>7/9/26</a:t>
             </a:fld>
             <a:endParaRPr lang="en-US"/>
           </a:p>
@@ -749,10 +759,9 @@
           <a:lstStyle/>
           <a:p>
             <a:r>
-              <a:rPr lang="en-US" smtClean="0"/>
+              <a:rPr lang="en-US"/>
               <a:t>Click to edit Master title style</a:t>
             </a:r>
-            <a:endParaRPr lang="en-US"/>
           </a:p>
         </p:txBody>
       </p:sp>
@@ -773,38 +782,37 @@
           <a:p>
             <a:pPr lvl="0"/>
             <a:r>
-              <a:rPr lang="en-US" smtClean="0"/>
+              <a:rPr lang="en-US"/>
               <a:t>Click to edit Master text styles</a:t>
             </a:r>
           </a:p>
           <a:p>
             <a:pPr lvl="1"/>
             <a:r>
-              <a:rPr lang="en-US" smtClean="0"/>
+              <a:rPr lang="en-US"/>
               <a:t>Second level</a:t>
             </a:r>
           </a:p>
           <a:p>
             <a:pPr lvl="2"/>
             <a:r>
-              <a:rPr lang="en-US" smtClean="0"/>
+              <a:rPr lang="en-US"/>
               <a:t>Third level</a:t>
             </a:r>
           </a:p>
           <a:p>
             <a:pPr lvl="3"/>
             <a:r>
-              <a:rPr lang="en-US" smtClean="0"/>
+              <a:rPr lang="en-US"/>
               <a:t>Fourth level</a:t>
             </a:r>
           </a:p>
           <a:p>
             <a:pPr lvl="4"/>
             <a:r>
-              <a:rPr lang="en-US" smtClean="0"/>
+              <a:rPr lang="en-US"/>
               <a:t>Fifth level</a:t>
             </a:r>
-            <a:endParaRPr lang="en-US"/>
           </a:p>
         </p:txBody>
       </p:sp>
@@ -825,7 +833,7 @@
           <a:p>
             <a:fld id="{5BCAD085-E8A6-8845-BD4E-CB4CCA059FC4}" type="datetimeFigureOut">
               <a:rPr lang="en-US" smtClean="0"/>
-              <a:t>1/27/13</a:t>
+              <a:t>7/9/26</a:t>
             </a:fld>
             <a:endParaRPr lang="en-US"/>
           </a:p>
@@ -928,10 +936,9 @@
           </a:lstStyle>
           <a:p>
             <a:r>
-              <a:rPr lang="en-US" smtClean="0"/>
+              <a:rPr lang="en-US"/>
               <a:t>Click to edit Master title style</a:t>
             </a:r>
-            <a:endParaRPr lang="en-US"/>
           </a:p>
         </p:txBody>
       </p:sp>
@@ -1048,7 +1055,7 @@
           <a:p>
             <a:pPr lvl="0"/>
             <a:r>
-              <a:rPr lang="en-US" smtClean="0"/>
+              <a:rPr lang="en-US"/>
               <a:t>Click to edit Master text styles</a:t>
             </a:r>
           </a:p>
@@ -1071,7 +1078,7 @@
           <a:p>
             <a:fld id="{5BCAD085-E8A6-8845-BD4E-CB4CCA059FC4}" type="datetimeFigureOut">
               <a:rPr lang="en-US" smtClean="0"/>
-              <a:t>1/27/13</a:t>
+              <a:t>7/9/26</a:t>
             </a:fld>
             <a:endParaRPr lang="en-US"/>
           </a:p>
@@ -1165,10 +1172,9 @@
           <a:lstStyle/>
           <a:p>
             <a:r>
-              <a:rPr lang="en-US" smtClean="0"/>
+              <a:rPr lang="en-US"/>
               <a:t>Click to edit Master title style</a:t>
             </a:r>
-            <a:endParaRPr lang="en-US"/>
           </a:p>
         </p:txBody>
       </p:sp>
@@ -1222,38 +1228,37 @@
           <a:p>
             <a:pPr lvl="0"/>
             <a:r>
-              <a:rPr lang="en-US" smtClean="0"/>
+              <a:rPr lang="en-US"/>
               <a:t>Click to edit Master text styles</a:t>
             </a:r>
           </a:p>
           <a:p>
             <a:pPr lvl="1"/>
             <a:r>
-              <a:rPr lang="en-US" smtClean="0"/>
+              <a:rPr lang="en-US"/>
               <a:t>Second level</a:t>
             </a:r>
           </a:p>
           <a:p>
             <a:pPr lvl="2"/>
             <a:r>
-              <a:rPr lang="en-US" smtClean="0"/>
+              <a:rPr lang="en-US"/>
               <a:t>Third level</a:t>
             </a:r>
           </a:p>
           <a:p>
             <a:pPr lvl="3"/>
             <a:r>
-              <a:rPr lang="en-US" smtClean="0"/>
+              <a:rPr lang="en-US"/>
               <a:t>Fourth level</a:t>
             </a:r>
           </a:p>
           <a:p>
             <a:pPr lvl="4"/>
             <a:r>
-              <a:rPr lang="en-US" smtClean="0"/>
+              <a:rPr lang="en-US"/>
               <a:t>Fifth level</a:t>
             </a:r>
-            <a:endParaRPr lang="en-US"/>
           </a:p>
         </p:txBody>
       </p:sp>
@@ -1307,38 +1312,37 @@
           <a:p>
             <a:pPr lvl="0"/>
             <a:r>
-              <a:rPr lang="en-US" smtClean="0"/>
+              <a:rPr lang="en-US"/>
               <a:t>Click to edit Master text styles</a:t>
             </a:r>
           </a:p>
           <a:p>
             <a:pPr lvl="1"/>
             <a:r>
-              <a:rPr lang="en-US" smtClean="0"/>
+              <a:rPr lang="en-US"/>
               <a:t>Second level</a:t>
             </a:r>
           </a:p>
           <a:p>
             <a:pPr lvl="2"/>
             <a:r>
-              <a:rPr lang="en-US" smtClean="0"/>
+              <a:rPr lang="en-US"/>
               <a:t>Third level</a:t>
             </a:r>
           </a:p>
           <a:p>
             <a:pPr lvl="3"/>
             <a:r>
-              <a:rPr lang="en-US" smtClean="0"/>
+              <a:rPr lang="en-US"/>
               <a:t>Fourth level</a:t>
             </a:r>
           </a:p>
           <a:p>
             <a:pPr lvl="4"/>
             <a:r>
-              <a:rPr lang="en-US" smtClean="0"/>
+              <a:rPr lang="en-US"/>
               <a:t>Fifth level</a:t>
             </a:r>
-            <a:endParaRPr lang="en-US"/>
           </a:p>
         </p:txBody>
       </p:sp>
@@ -1359,7 +1363,7 @@
           <a:p>
             <a:fld id="{5BCAD085-E8A6-8845-BD4E-CB4CCA059FC4}" type="datetimeFigureOut">
               <a:rPr lang="en-US" smtClean="0"/>
-              <a:t>1/27/13</a:t>
+              <a:t>7/9/26</a:t>
             </a:fld>
             <a:endParaRPr lang="en-US"/>
           </a:p>
@@ -1457,10 +1461,9 @@
           </a:lstStyle>
           <a:p>
             <a:r>
-              <a:rPr lang="en-US" smtClean="0"/>
+              <a:rPr lang="en-US"/>
               <a:t>Click to edit Master title style</a:t>
             </a:r>
-            <a:endParaRPr lang="en-US"/>
           </a:p>
         </p:txBody>
       </p:sp>
@@ -1523,7 +1526,7 @@
           <a:p>
             <a:pPr lvl="0"/>
             <a:r>
-              <a:rPr lang="en-US" smtClean="0"/>
+              <a:rPr lang="en-US"/>
               <a:t>Click to edit Master text styles</a:t>
             </a:r>
           </a:p>
@@ -1579,38 +1582,37 @@
           <a:p>
             <a:pPr lvl="0"/>
             <a:r>
-              <a:rPr lang="en-US" smtClean="0"/>
+              <a:rPr lang="en-US"/>
               <a:t>Click to edit Master text styles</a:t>
             </a:r>
           </a:p>
           <a:p>
             <a:pPr lvl="1"/>
             <a:r>
-              <a:rPr lang="en-US" smtClean="0"/>
+              <a:rPr lang="en-US"/>
               <a:t>Second level</a:t>
             </a:r>
           </a:p>
           <a:p>
             <a:pPr lvl="2"/>
             <a:r>
-              <a:rPr lang="en-US" smtClean="0"/>
+              <a:rPr lang="en-US"/>
               <a:t>Third level</a:t>
             </a:r>
           </a:p>
           <a:p>
             <a:pPr lvl="3"/>
             <a:r>
-              <a:rPr lang="en-US" smtClean="0"/>
+              <a:rPr lang="en-US"/>
               <a:t>Fourth level</a:t>
             </a:r>
           </a:p>
           <a:p>
             <a:pPr lvl="4"/>
             <a:r>
-              <a:rPr lang="en-US" smtClean="0"/>
+              <a:rPr lang="en-US"/>
               <a:t>Fifth level</a:t>
             </a:r>
-            <a:endParaRPr lang="en-US"/>
           </a:p>
         </p:txBody>
       </p:sp>
@@ -1673,7 +1675,7 @@
           <a:p>
             <a:pPr lvl="0"/>
             <a:r>
-              <a:rPr lang="en-US" smtClean="0"/>
+              <a:rPr lang="en-US"/>
               <a:t>Click to edit Master text styles</a:t>
             </a:r>
           </a:p>
@@ -1729,38 +1731,37 @@
           <a:p>
             <a:pPr lvl="0"/>
             <a:r>
-              <a:rPr lang="en-US" smtClean="0"/>
+              <a:rPr lang="en-US"/>
               <a:t>Click to edit Master text styles</a:t>
             </a:r>
           </a:p>
           <a:p>
             <a:pPr lvl="1"/>
             <a:r>
-              <a:rPr lang="en-US" smtClean="0"/>
+              <a:rPr lang="en-US"/>
               <a:t>Second level</a:t>
             </a:r>
           </a:p>
           <a:p>
             <a:pPr lvl="2"/>
             <a:r>
-              <a:rPr lang="en-US" smtClean="0"/>
+              <a:rPr lang="en-US"/>
               <a:t>Third level</a:t>
             </a:r>
           </a:p>
           <a:p>
             <a:pPr lvl="3"/>
             <a:r>
-              <a:rPr lang="en-US" smtClean="0"/>
+              <a:rPr lang="en-US"/>
               <a:t>Fourth level</a:t>
             </a:r>
           </a:p>
           <a:p>
             <a:pPr lvl="4"/>
             <a:r>
-              <a:rPr lang="en-US" smtClean="0"/>
+              <a:rPr lang="en-US"/>
               <a:t>Fifth level</a:t>
             </a:r>
-            <a:endParaRPr lang="en-US"/>
           </a:p>
         </p:txBody>
       </p:sp>
@@ -1781,7 +1782,7 @@
           <a:p>
             <a:fld id="{5BCAD085-E8A6-8845-BD4E-CB4CCA059FC4}" type="datetimeFigureOut">
               <a:rPr lang="en-US" smtClean="0"/>
-              <a:t>1/27/13</a:t>
+              <a:t>7/9/26</a:t>
             </a:fld>
             <a:endParaRPr lang="en-US"/>
           </a:p>
@@ -1875,10 +1876,9 @@
           <a:lstStyle/>
           <a:p>
             <a:r>
-              <a:rPr lang="en-US" smtClean="0"/>
+              <a:rPr lang="en-US"/>
               <a:t>Click to edit Master title style</a:t>
             </a:r>
-            <a:endParaRPr lang="en-US"/>
           </a:p>
         </p:txBody>
       </p:sp>
@@ -1899,7 +1899,7 @@
           <a:p>
             <a:fld id="{5BCAD085-E8A6-8845-BD4E-CB4CCA059FC4}" type="datetimeFigureOut">
               <a:rPr lang="en-US" smtClean="0"/>
-              <a:t>1/27/13</a:t>
+              <a:t>7/9/26</a:t>
             </a:fld>
             <a:endParaRPr lang="en-US"/>
           </a:p>
@@ -1994,7 +1994,7 @@
           <a:p>
             <a:fld id="{5BCAD085-E8A6-8845-BD4E-CB4CCA059FC4}" type="datetimeFigureOut">
               <a:rPr lang="en-US" smtClean="0"/>
-              <a:t>1/27/13</a:t>
+              <a:t>7/9/26</a:t>
             </a:fld>
             <a:endParaRPr lang="en-US"/>
           </a:p>
@@ -2097,10 +2097,9 @@
           </a:lstStyle>
           <a:p>
             <a:r>
-              <a:rPr lang="en-US" smtClean="0"/>
+              <a:rPr lang="en-US"/>
               <a:t>Click to edit Master title style</a:t>
             </a:r>
-            <a:endParaRPr lang="en-US"/>
           </a:p>
         </p:txBody>
       </p:sp>
@@ -2154,38 +2153,37 @@
           <a:p>
             <a:pPr lvl="0"/>
             <a:r>
-              <a:rPr lang="en-US" smtClean="0"/>
+              <a:rPr lang="en-US"/>
               <a:t>Click to edit Master text styles</a:t>
             </a:r>
           </a:p>
           <a:p>
             <a:pPr lvl="1"/>
             <a:r>
-              <a:rPr lang="en-US" smtClean="0"/>
+              <a:rPr lang="en-US"/>
               <a:t>Second level</a:t>
             </a:r>
           </a:p>
           <a:p>
             <a:pPr lvl="2"/>
             <a:r>
-              <a:rPr lang="en-US" smtClean="0"/>
+              <a:rPr lang="en-US"/>
               <a:t>Third level</a:t>
             </a:r>
           </a:p>
           <a:p>
             <a:pPr lvl="3"/>
             <a:r>
-              <a:rPr lang="en-US" smtClean="0"/>
+              <a:rPr lang="en-US"/>
               <a:t>Fourth level</a:t>
             </a:r>
           </a:p>
           <a:p>
             <a:pPr lvl="4"/>
             <a:r>
-              <a:rPr lang="en-US" smtClean="0"/>
+              <a:rPr lang="en-US"/>
               <a:t>Fifth level</a:t>
             </a:r>
-            <a:endParaRPr lang="en-US"/>
           </a:p>
         </p:txBody>
       </p:sp>
@@ -2248,7 +2246,7 @@
           <a:p>
             <a:pPr lvl="0"/>
             <a:r>
-              <a:rPr lang="en-US" smtClean="0"/>
+              <a:rPr lang="en-US"/>
               <a:t>Click to edit Master text styles</a:t>
             </a:r>
           </a:p>
@@ -2271,7 +2269,7 @@
           <a:p>
             <a:fld id="{5BCAD085-E8A6-8845-BD4E-CB4CCA059FC4}" type="datetimeFigureOut">
               <a:rPr lang="en-US" smtClean="0"/>
-              <a:t>1/27/13</a:t>
+              <a:t>7/9/26</a:t>
             </a:fld>
             <a:endParaRPr lang="en-US"/>
           </a:p>
@@ -2374,10 +2372,9 @@
           </a:lstStyle>
           <a:p>
             <a:r>
-              <a:rPr lang="en-US" smtClean="0"/>
+              <a:rPr lang="en-US"/>
               <a:t>Click to edit Master title style</a:t>
             </a:r>
-            <a:endParaRPr lang="en-US"/>
           </a:p>
         </p:txBody>
       </p:sp>
@@ -2501,7 +2498,7 @@
           <a:p>
             <a:pPr lvl="0"/>
             <a:r>
-              <a:rPr lang="en-US" smtClean="0"/>
+              <a:rPr lang="en-US"/>
               <a:t>Click to edit Master text styles</a:t>
             </a:r>
           </a:p>
@@ -2524,7 +2521,7 @@
           <a:p>
             <a:fld id="{5BCAD085-E8A6-8845-BD4E-CB4CCA059FC4}" type="datetimeFigureOut">
               <a:rPr lang="en-US" smtClean="0"/>
-              <a:t>1/27/13</a:t>
+              <a:t>7/9/26</a:t>
             </a:fld>
             <a:endParaRPr lang="en-US"/>
           </a:p>
@@ -2633,10 +2630,9 @@
           <a:lstStyle/>
           <a:p>
             <a:r>
-              <a:rPr lang="en-US" smtClean="0"/>
+              <a:rPr lang="en-US"/>
               <a:t>Click to edit Master title style</a:t>
             </a:r>
-            <a:endParaRPr lang="en-US"/>
           </a:p>
         </p:txBody>
       </p:sp>
@@ -2667,38 +2663,37 @@
           <a:p>
             <a:pPr lvl="0"/>
             <a:r>
-              <a:rPr lang="en-US" smtClean="0"/>
+              <a:rPr lang="en-US"/>
               <a:t>Click to edit Master text styles</a:t>
             </a:r>
           </a:p>
           <a:p>
             <a:pPr lvl="1"/>
             <a:r>
-              <a:rPr lang="en-US" smtClean="0"/>
+              <a:rPr lang="en-US"/>
               <a:t>Second level</a:t>
             </a:r>
           </a:p>
           <a:p>
             <a:pPr lvl="2"/>
             <a:r>
-              <a:rPr lang="en-US" smtClean="0"/>
+              <a:rPr lang="en-US"/>
               <a:t>Third level</a:t>
             </a:r>
           </a:p>
           <a:p>
             <a:pPr lvl="3"/>
             <a:r>
-              <a:rPr lang="en-US" smtClean="0"/>
+              <a:rPr lang="en-US"/>
               <a:t>Fourth level</a:t>
             </a:r>
           </a:p>
           <a:p>
             <a:pPr lvl="4"/>
             <a:r>
-              <a:rPr lang="en-US" smtClean="0"/>
+              <a:rPr lang="en-US"/>
               <a:t>Fifth level</a:t>
             </a:r>
-            <a:endParaRPr lang="en-US"/>
           </a:p>
         </p:txBody>
       </p:sp>
@@ -2737,7 +2732,7 @@
           <a:p>
             <a:fld id="{5BCAD085-E8A6-8845-BD4E-CB4CCA059FC4}" type="datetimeFigureOut">
               <a:rPr lang="en-US" smtClean="0"/>
-              <a:t>1/27/13</a:t>
+              <a:t>7/9/26</a:t>
             </a:fld>
             <a:endParaRPr lang="en-US"/>
           </a:p>
@@ -3096,7 +3091,7 @@
 </file>
 
 <file path=ppt/slides/slide1.xml><?xml version="1.0" encoding="utf-8"?>
-<p:sld xmlns:a="http://schemas.openxmlformats.org/drawingml/2006/main" xmlns:p="http://schemas.openxmlformats.org/presentationml/2006/main" xmlns:r="http://schemas.openxmlformats.org/officeDocument/2006/relationships">
+<p:sld xmlns:a="http://schemas.openxmlformats.org/drawingml/2006/main" xmlns:r="http://schemas.openxmlformats.org/officeDocument/2006/relationships" xmlns:p="http://schemas.openxmlformats.org/presentationml/2006/main">
   <p:cSld>
     <p:bg>
       <p:bgPr>
@@ -3112,7 +3107,14 @@
         <p:cNvGrpSpPr/>
         <p:nvPr/>
       </p:nvGrpSpPr>
-      <p:grpSpPr/>
+      <p:grpSpPr>
+        <a:xfrm>
+          <a:off x="0" y="0"/>
+          <a:ext cx="0" cy="0"/>
+          <a:chOff x="0" y="0"/>
+          <a:chExt cx="0" cy="0"/>
+        </a:xfrm>
+      </p:grpSpPr>
       <p:sp>
         <p:nvSpPr>
           <p:cNvPr id="2" name="Rectangle 1"/>
@@ -3149,7 +3151,7 @@
           </a:fontRef>
         </p:style>
         <p:txBody>
-          <a:bodyPr rtlCol="0" anchor="ctr" wrap="square" lIns="274320" tIns="182880"/>
+          <a:bodyPr wrap="square" lIns="274320" tIns="182880" rtlCol="0" anchor="ctr"/>
           <a:lstStyle/>
           <a:p>
             <a:pPr algn="ctr">
@@ -3160,16 +3162,144 @@
               </a:defRPr>
             </a:pPr>
             <a:r>
-              <a:t>Ứng dụng mạng nơ-ron nhân tạo</a:t>
-            </a:r>
-            <a:br/>
-            <a:r>
-              <a:t>làm hàm heuristic cho thuật toán A*</a:t>
-            </a:r>
-            <a:br/>
-            <a:r>
-              <a:t>trong bài toán tìm đường mê cung</a:t>
-            </a:r>
+              <a:rPr dirty="0"/>
+              <a:t>Ứng </a:t>
+            </a:r>
+            <a:r>
+              <a:rPr dirty="0" err="1"/>
+              <a:t>dụng</a:t>
+            </a:r>
+            <a:r>
+              <a:rPr dirty="0"/>
+              <a:t> </a:t>
+            </a:r>
+            <a:r>
+              <a:rPr dirty="0" err="1"/>
+              <a:t>mạng</a:t>
+            </a:r>
+            <a:r>
+              <a:rPr dirty="0"/>
+              <a:t> </a:t>
+            </a:r>
+            <a:r>
+              <a:rPr dirty="0" err="1"/>
+              <a:t>nơ-ron</a:t>
+            </a:r>
+            <a:r>
+              <a:rPr dirty="0"/>
+              <a:t> </a:t>
+            </a:r>
+            <a:r>
+              <a:rPr dirty="0" err="1"/>
+              <a:t>nhân</a:t>
+            </a:r>
+            <a:r>
+              <a:rPr dirty="0"/>
+              <a:t> </a:t>
+            </a:r>
+            <a:r>
+              <a:rPr dirty="0" err="1"/>
+              <a:t>tạo</a:t>
+            </a:r>
+            <a:br>
+              <a:rPr dirty="0"/>
+            </a:br>
+            <a:r>
+              <a:rPr dirty="0" err="1"/>
+              <a:t>làm</a:t>
+            </a:r>
+            <a:r>
+              <a:rPr dirty="0"/>
+              <a:t> </a:t>
+            </a:r>
+            <a:r>
+              <a:rPr dirty="0" err="1"/>
+              <a:t>hàm</a:t>
+            </a:r>
+            <a:r>
+              <a:rPr dirty="0"/>
+              <a:t> heuristic </a:t>
+            </a:r>
+            <a:r>
+              <a:rPr dirty="0" err="1"/>
+              <a:t>cho</a:t>
+            </a:r>
+            <a:r>
+              <a:rPr dirty="0"/>
+              <a:t> </a:t>
+            </a:r>
+            <a:r>
+              <a:rPr dirty="0" err="1"/>
+              <a:t>thuật</a:t>
+            </a:r>
+            <a:r>
+              <a:rPr dirty="0"/>
+              <a:t> </a:t>
+            </a:r>
+            <a:r>
+              <a:rPr dirty="0" err="1"/>
+              <a:t>toán</a:t>
+            </a:r>
+            <a:r>
+              <a:rPr dirty="0"/>
+              <a:t> A*</a:t>
+            </a:r>
+            <a:br>
+              <a:rPr dirty="0"/>
+            </a:br>
+            <a:r>
+              <a:rPr dirty="0" err="1"/>
+              <a:t>trong</a:t>
+            </a:r>
+            <a:r>
+              <a:rPr dirty="0"/>
+              <a:t> </a:t>
+            </a:r>
+            <a:r>
+              <a:rPr dirty="0" err="1"/>
+              <a:t>bài</a:t>
+            </a:r>
+            <a:r>
+              <a:rPr dirty="0"/>
+              <a:t> </a:t>
+            </a:r>
+            <a:r>
+              <a:rPr dirty="0" err="1"/>
+              <a:t>toán</a:t>
+            </a:r>
+            <a:r>
+              <a:rPr dirty="0"/>
+              <a:t> </a:t>
+            </a:r>
+            <a:r>
+              <a:rPr dirty="0" err="1"/>
+              <a:t>tìm</a:t>
+            </a:r>
+            <a:r>
+              <a:rPr dirty="0"/>
+              <a:t> </a:t>
+            </a:r>
+            <a:r>
+              <a:rPr dirty="0" err="1"/>
+              <a:t>đường</a:t>
+            </a:r>
+            <a:r>
+              <a:rPr dirty="0"/>
+              <a:t> </a:t>
+            </a:r>
+            <a:r>
+              <a:rPr dirty="0" err="1"/>
+              <a:t>mê</a:t>
+            </a:r>
+            <a:r>
+              <a:rPr dirty="0"/>
+              <a:t> </a:t>
+            </a:r>
+            <a:r>
+              <a:rPr dirty="0" err="1"/>
+              <a:t>cung</a:t>
+            </a:r>
+            <a:endParaRPr dirty="0"/>
           </a:p>
           <a:p>
             <a:pPr>
@@ -3177,6 +3307,7 @@
                 <a:spcPts val="1400"/>
               </a:spcAft>
             </a:pPr>
+            <a:endParaRPr dirty="0"/>
           </a:p>
           <a:p>
             <a:pPr algn="ctr">
@@ -3187,7 +3318,27 @@
               </a:defRPr>
             </a:pPr>
             <a:r>
-              <a:t>Nhóm Tờ Linh: Nguyễn Quốc Minh – Võ Nguyễn Tấn Tài</a:t>
+              <a:rPr dirty="0" err="1"/>
+              <a:t>Nhóm</a:t>
+            </a:r>
+            <a:r>
+              <a:rPr dirty="0"/>
+              <a:t> </a:t>
+            </a:r>
+            <a:r>
+              <a:rPr dirty="0" err="1"/>
+              <a:t>Tờ</a:t>
+            </a:r>
+            <a:r>
+              <a:rPr dirty="0"/>
+              <a:t> Linh: Nguyễn Quốc Minh</a:t>
+            </a:r>
+            <a:r>
+              <a:rPr lang="vi-VN"/>
+              <a:t>,</a:t>
+            </a:r>
+            <a:r>
+              <a:t> Võ Nguyễn Tấn Tài</a:t>
             </a:r>
           </a:p>
           <a:p>
@@ -3199,7 +3350,32 @@
               </a:defRPr>
             </a:pPr>
             <a:r>
-              <a:t>Học kỳ II năm học 2025–2026</a:t>
+              <a:rPr dirty="0"/>
+              <a:t>Học </a:t>
+            </a:r>
+            <a:r>
+              <a:rPr dirty="0" err="1"/>
+              <a:t>kỳ</a:t>
+            </a:r>
+            <a:r>
+              <a:rPr dirty="0"/>
+              <a:t> II </a:t>
+            </a:r>
+            <a:r>
+              <a:rPr dirty="0" err="1"/>
+              <a:t>năm</a:t>
+            </a:r>
+            <a:r>
+              <a:rPr dirty="0"/>
+              <a:t> </a:t>
+            </a:r>
+            <a:r>
+              <a:rPr dirty="0" err="1"/>
+              <a:t>học</a:t>
+            </a:r>
+            <a:r>
+              <a:rPr dirty="0"/>
+              <a:t> 2025–2026</a:t>
             </a:r>
           </a:p>
         </p:txBody>
@@ -3213,7 +3389,7 @@
 </file>
 
 <file path=ppt/slides/slide10.xml><?xml version="1.0" encoding="utf-8"?>
-<p:sld xmlns:a="http://schemas.openxmlformats.org/drawingml/2006/main" xmlns:p="http://schemas.openxmlformats.org/presentationml/2006/main" xmlns:r="http://schemas.openxmlformats.org/officeDocument/2006/relationships">
+<p:sld xmlns:a="http://schemas.openxmlformats.org/drawingml/2006/main" xmlns:r="http://schemas.openxmlformats.org/officeDocument/2006/relationships" xmlns:p="http://schemas.openxmlformats.org/presentationml/2006/main">
   <p:cSld>
     <p:bg>
       <p:bgPr>
@@ -3229,7 +3405,14 @@
         <p:cNvGrpSpPr/>
         <p:nvPr/>
       </p:nvGrpSpPr>
-      <p:grpSpPr/>
+      <p:grpSpPr>
+        <a:xfrm>
+          <a:off x="0" y="0"/>
+          <a:ext cx="0" cy="0"/>
+          <a:chOff x="0" y="0"/>
+          <a:chExt cx="0" cy="0"/>
+        </a:xfrm>
+      </p:grpSpPr>
       <p:sp>
         <p:nvSpPr>
           <p:cNvPr id="2" name="Rectangle 1"/>
@@ -3266,7 +3449,7 @@
           </a:fontRef>
         </p:style>
         <p:txBody>
-          <a:bodyPr rtlCol="0" anchor="ctr" wrap="square" lIns="457200" tIns="137160"/>
+          <a:bodyPr wrap="square" lIns="457200" tIns="137160" rtlCol="0" anchor="ctr"/>
           <a:lstStyle/>
           <a:p>
             <a:pPr algn="ctr">
@@ -3389,7 +3572,7 @@
 </file>
 
 <file path=ppt/slides/slide11.xml><?xml version="1.0" encoding="utf-8"?>
-<p:sld xmlns:a="http://schemas.openxmlformats.org/drawingml/2006/main" xmlns:p="http://schemas.openxmlformats.org/presentationml/2006/main" xmlns:r="http://schemas.openxmlformats.org/officeDocument/2006/relationships">
+<p:sld xmlns:a="http://schemas.openxmlformats.org/drawingml/2006/main" xmlns:r="http://schemas.openxmlformats.org/officeDocument/2006/relationships" xmlns:p="http://schemas.openxmlformats.org/presentationml/2006/main">
   <p:cSld>
     <p:bg>
       <p:bgPr>
@@ -3405,7 +3588,14 @@
         <p:cNvGrpSpPr/>
         <p:nvPr/>
       </p:nvGrpSpPr>
-      <p:grpSpPr/>
+      <p:grpSpPr>
+        <a:xfrm>
+          <a:off x="0" y="0"/>
+          <a:ext cx="0" cy="0"/>
+          <a:chOff x="0" y="0"/>
+          <a:chExt cx="0" cy="0"/>
+        </a:xfrm>
+      </p:grpSpPr>
       <p:sp>
         <p:nvSpPr>
           <p:cNvPr id="2" name="Rectangle 1"/>
@@ -3442,7 +3632,7 @@
           </a:fontRef>
         </p:style>
         <p:txBody>
-          <a:bodyPr rtlCol="0" anchor="ctr" wrap="square" lIns="457200" tIns="137160"/>
+          <a:bodyPr wrap="square" lIns="457200" tIns="137160" rtlCol="0" anchor="ctr"/>
           <a:lstStyle/>
           <a:p>
             <a:pPr algn="ctr">
@@ -3565,7 +3755,7 @@
 </file>
 
 <file path=ppt/slides/slide12.xml><?xml version="1.0" encoding="utf-8"?>
-<p:sld xmlns:a="http://schemas.openxmlformats.org/drawingml/2006/main" xmlns:p="http://schemas.openxmlformats.org/presentationml/2006/main" xmlns:r="http://schemas.openxmlformats.org/officeDocument/2006/relationships">
+<p:sld xmlns:a="http://schemas.openxmlformats.org/drawingml/2006/main" xmlns:r="http://schemas.openxmlformats.org/officeDocument/2006/relationships" xmlns:p="http://schemas.openxmlformats.org/presentationml/2006/main">
   <p:cSld>
     <p:bg>
       <p:bgPr>
@@ -3581,7 +3771,14 @@
         <p:cNvGrpSpPr/>
         <p:nvPr/>
       </p:nvGrpSpPr>
-      <p:grpSpPr/>
+      <p:grpSpPr>
+        <a:xfrm>
+          <a:off x="0" y="0"/>
+          <a:ext cx="0" cy="0"/>
+          <a:chOff x="0" y="0"/>
+          <a:chExt cx="0" cy="0"/>
+        </a:xfrm>
+      </p:grpSpPr>
       <p:sp>
         <p:nvSpPr>
           <p:cNvPr id="2" name="Rectangle 1"/>
@@ -3618,7 +3815,7 @@
           </a:fontRef>
         </p:style>
         <p:txBody>
-          <a:bodyPr rtlCol="0" anchor="ctr" wrap="square" lIns="457200" tIns="137160"/>
+          <a:bodyPr wrap="square" lIns="457200" tIns="137160" rtlCol="0" anchor="ctr"/>
           <a:lstStyle/>
           <a:p>
             <a:pPr algn="ctr">
@@ -3735,7 +3932,7 @@
 </file>
 
 <file path=ppt/slides/slide13.xml><?xml version="1.0" encoding="utf-8"?>
-<p:sld xmlns:a="http://schemas.openxmlformats.org/drawingml/2006/main" xmlns:p="http://schemas.openxmlformats.org/presentationml/2006/main" xmlns:r="http://schemas.openxmlformats.org/officeDocument/2006/relationships">
+<p:sld xmlns:a="http://schemas.openxmlformats.org/drawingml/2006/main" xmlns:r="http://schemas.openxmlformats.org/officeDocument/2006/relationships" xmlns:p="http://schemas.openxmlformats.org/presentationml/2006/main">
   <p:cSld>
     <p:bg>
       <p:bgPr>
@@ -3751,7 +3948,14 @@
         <p:cNvGrpSpPr/>
         <p:nvPr/>
       </p:nvGrpSpPr>
-      <p:grpSpPr/>
+      <p:grpSpPr>
+        <a:xfrm>
+          <a:off x="0" y="0"/>
+          <a:ext cx="0" cy="0"/>
+          <a:chOff x="0" y="0"/>
+          <a:chExt cx="0" cy="0"/>
+        </a:xfrm>
+      </p:grpSpPr>
       <p:sp>
         <p:nvSpPr>
           <p:cNvPr id="2" name="Rectangle 1"/>
@@ -3788,7 +3992,7 @@
           </a:fontRef>
         </p:style>
         <p:txBody>
-          <a:bodyPr rtlCol="0" anchor="ctr" wrap="square" lIns="457200" tIns="137160"/>
+          <a:bodyPr wrap="square" lIns="457200" tIns="137160" rtlCol="0" anchor="ctr"/>
           <a:lstStyle/>
           <a:p>
             <a:pPr algn="ctr">
@@ -3920,7 +4124,7 @@
 </file>
 
 <file path=ppt/slides/slide14.xml><?xml version="1.0" encoding="utf-8"?>
-<p:sld xmlns:a="http://schemas.openxmlformats.org/drawingml/2006/main" xmlns:p="http://schemas.openxmlformats.org/presentationml/2006/main" xmlns:r="http://schemas.openxmlformats.org/officeDocument/2006/relationships">
+<p:sld xmlns:a="http://schemas.openxmlformats.org/drawingml/2006/main" xmlns:r="http://schemas.openxmlformats.org/officeDocument/2006/relationships" xmlns:p="http://schemas.openxmlformats.org/presentationml/2006/main">
   <p:cSld>
     <p:bg>
       <p:bgPr>
@@ -3936,7 +4140,14 @@
         <p:cNvGrpSpPr/>
         <p:nvPr/>
       </p:nvGrpSpPr>
-      <p:grpSpPr/>
+      <p:grpSpPr>
+        <a:xfrm>
+          <a:off x="0" y="0"/>
+          <a:ext cx="0" cy="0"/>
+          <a:chOff x="0" y="0"/>
+          <a:chExt cx="0" cy="0"/>
+        </a:xfrm>
+      </p:grpSpPr>
       <p:sp>
         <p:nvSpPr>
           <p:cNvPr id="2" name="Rectangle 1"/>
@@ -3973,7 +4184,7 @@
           </a:fontRef>
         </p:style>
         <p:txBody>
-          <a:bodyPr rtlCol="0" anchor="ctr" wrap="square" lIns="457200" tIns="137160"/>
+          <a:bodyPr wrap="square" lIns="457200" tIns="137160" rtlCol="0" anchor="ctr"/>
           <a:lstStyle/>
           <a:p>
             <a:pPr algn="ctr">
@@ -4105,7 +4316,7 @@
 </file>
 
 <file path=ppt/slides/slide15.xml><?xml version="1.0" encoding="utf-8"?>
-<p:sld xmlns:a="http://schemas.openxmlformats.org/drawingml/2006/main" xmlns:p="http://schemas.openxmlformats.org/presentationml/2006/main" xmlns:r="http://schemas.openxmlformats.org/officeDocument/2006/relationships">
+<p:sld xmlns:a="http://schemas.openxmlformats.org/drawingml/2006/main" xmlns:r="http://schemas.openxmlformats.org/officeDocument/2006/relationships" xmlns:p="http://schemas.openxmlformats.org/presentationml/2006/main">
   <p:cSld>
     <p:bg>
       <p:bgPr>
@@ -4121,7 +4332,14 @@
         <p:cNvGrpSpPr/>
         <p:nvPr/>
       </p:nvGrpSpPr>
-      <p:grpSpPr/>
+      <p:grpSpPr>
+        <a:xfrm>
+          <a:off x="0" y="0"/>
+          <a:ext cx="0" cy="0"/>
+          <a:chOff x="0" y="0"/>
+          <a:chExt cx="0" cy="0"/>
+        </a:xfrm>
+      </p:grpSpPr>
       <p:sp>
         <p:nvSpPr>
           <p:cNvPr id="2" name="Rectangle 1"/>
@@ -4158,7 +4376,7 @@
           </a:fontRef>
         </p:style>
         <p:txBody>
-          <a:bodyPr rtlCol="0" anchor="ctr" wrap="square" lIns="457200" tIns="137160"/>
+          <a:bodyPr wrap="square" lIns="457200" tIns="137160" rtlCol="0" anchor="ctr"/>
           <a:lstStyle/>
           <a:p>
             <a:pPr algn="ctr">
@@ -4193,9 +4411,27 @@
                 <a:tableStyleId>{5C22544A-7EE6-4342-B048-85BDC9FD1C3A}</a:tableStyleId>
               </a:tblPr>
               <a:tblGrid>
-                <a:gridCol w="1828800"/>
-                <a:gridCol w="3657600"/>
-                <a:gridCol w="3657600"/>
+                <a:gridCol w="1828800">
+                  <a:extLst>
+                    <a:ext uri="{9D8B030D-6E8A-4147-A177-3AD203B41FA5}">
+                      <a16:colId xmlns:a16="http://schemas.microsoft.com/office/drawing/2014/main" val="20000"/>
+                    </a:ext>
+                  </a:extLst>
+                </a:gridCol>
+                <a:gridCol w="3657600">
+                  <a:extLst>
+                    <a:ext uri="{9D8B030D-6E8A-4147-A177-3AD203B41FA5}">
+                      <a16:colId xmlns:a16="http://schemas.microsoft.com/office/drawing/2014/main" val="20001"/>
+                    </a:ext>
+                  </a:extLst>
+                </a:gridCol>
+                <a:gridCol w="3657600">
+                  <a:extLst>
+                    <a:ext uri="{9D8B030D-6E8A-4147-A177-3AD203B41FA5}">
+                      <a16:colId xmlns:a16="http://schemas.microsoft.com/office/drawing/2014/main" val="20002"/>
+                    </a:ext>
+                  </a:extLst>
+                </a:gridCol>
               </a:tblGrid>
               <a:tr h="457200">
                 <a:tc>
@@ -4204,7 +4440,7 @@
                     <a:lstStyle/>
                     <a:p>
                       <a:pPr algn="ctr">
-                        <a:defRPr b="1" sz="1800">
+                        <a:defRPr sz="1800" b="1">
                           <a:solidFill>
                             <a:srgbClr val="FFFFFF"/>
                           </a:solidFill>
@@ -4227,7 +4463,7 @@
                     <a:lstStyle/>
                     <a:p>
                       <a:pPr algn="ctr">
-                        <a:defRPr b="1" sz="1800">
+                        <a:defRPr sz="1800" b="1">
                           <a:solidFill>
                             <a:srgbClr val="FFFFFF"/>
                           </a:solidFill>
@@ -4250,7 +4486,7 @@
                     <a:lstStyle/>
                     <a:p>
                       <a:pPr algn="ctr">
-                        <a:defRPr b="1" sz="1800">
+                        <a:defRPr sz="1800" b="1">
                           <a:solidFill>
                             <a:srgbClr val="FFFFFF"/>
                           </a:solidFill>
@@ -4267,6 +4503,11 @@
                     </a:solidFill>
                   </a:tcPr>
                 </a:tc>
+                <a:extLst>
+                  <a:ext uri="{0D108BD9-81ED-4DB2-BD59-A6C34878D82A}">
+                    <a16:rowId xmlns:a16="http://schemas.microsoft.com/office/drawing/2014/main" val="10000"/>
+                  </a:ext>
+                </a:extLst>
               </a:tr>
               <a:tr h="457200">
                 <a:tc>
@@ -4326,6 +4567,11 @@
                   </a:txBody>
                   <a:tcPr/>
                 </a:tc>
+                <a:extLst>
+                  <a:ext uri="{0D108BD9-81ED-4DB2-BD59-A6C34878D82A}">
+                    <a16:rowId xmlns:a16="http://schemas.microsoft.com/office/drawing/2014/main" val="10001"/>
+                  </a:ext>
+                </a:extLst>
               </a:tr>
               <a:tr h="457200">
                 <a:tc>
@@ -4385,6 +4631,11 @@
                   </a:txBody>
                   <a:tcPr/>
                 </a:tc>
+                <a:extLst>
+                  <a:ext uri="{0D108BD9-81ED-4DB2-BD59-A6C34878D82A}">
+                    <a16:rowId xmlns:a16="http://schemas.microsoft.com/office/drawing/2014/main" val="10002"/>
+                  </a:ext>
+                </a:extLst>
               </a:tr>
               <a:tr h="457200">
                 <a:tc>
@@ -4444,6 +4695,11 @@
                   </a:txBody>
                   <a:tcPr/>
                 </a:tc>
+                <a:extLst>
+                  <a:ext uri="{0D108BD9-81ED-4DB2-BD59-A6C34878D82A}">
+                    <a16:rowId xmlns:a16="http://schemas.microsoft.com/office/drawing/2014/main" val="10003"/>
+                  </a:ext>
+                </a:extLst>
               </a:tr>
               <a:tr h="457200">
                 <a:tc>
@@ -4503,6 +4759,11 @@
                   </a:txBody>
                   <a:tcPr/>
                 </a:tc>
+                <a:extLst>
+                  <a:ext uri="{0D108BD9-81ED-4DB2-BD59-A6C34878D82A}">
+                    <a16:rowId xmlns:a16="http://schemas.microsoft.com/office/drawing/2014/main" val="10004"/>
+                  </a:ext>
+                </a:extLst>
               </a:tr>
               <a:tr h="457200">
                 <a:tc>
@@ -4562,6 +4823,11 @@
                   </a:txBody>
                   <a:tcPr/>
                 </a:tc>
+                <a:extLst>
+                  <a:ext uri="{0D108BD9-81ED-4DB2-BD59-A6C34878D82A}">
+                    <a16:rowId xmlns:a16="http://schemas.microsoft.com/office/drawing/2014/main" val="10005"/>
+                  </a:ext>
+                </a:extLst>
               </a:tr>
             </a:tbl>
           </a:graphicData>
@@ -4644,7 +4910,7 @@
 </file>
 
 <file path=ppt/slides/slide16.xml><?xml version="1.0" encoding="utf-8"?>
-<p:sld xmlns:a="http://schemas.openxmlformats.org/drawingml/2006/main" xmlns:p="http://schemas.openxmlformats.org/presentationml/2006/main" xmlns:r="http://schemas.openxmlformats.org/officeDocument/2006/relationships">
+<p:sld xmlns:a="http://schemas.openxmlformats.org/drawingml/2006/main" xmlns:r="http://schemas.openxmlformats.org/officeDocument/2006/relationships" xmlns:p="http://schemas.openxmlformats.org/presentationml/2006/main">
   <p:cSld>
     <p:bg>
       <p:bgPr>
@@ -4660,7 +4926,14 @@
         <p:cNvGrpSpPr/>
         <p:nvPr/>
       </p:nvGrpSpPr>
-      <p:grpSpPr/>
+      <p:grpSpPr>
+        <a:xfrm>
+          <a:off x="0" y="0"/>
+          <a:ext cx="0" cy="0"/>
+          <a:chOff x="0" y="0"/>
+          <a:chExt cx="0" cy="0"/>
+        </a:xfrm>
+      </p:grpSpPr>
       <p:sp>
         <p:nvSpPr>
           <p:cNvPr id="2" name="Rectangle 1"/>
@@ -4697,7 +4970,7 @@
           </a:fontRef>
         </p:style>
         <p:txBody>
-          <a:bodyPr rtlCol="0" anchor="ctr" wrap="square" lIns="457200" tIns="137160"/>
+          <a:bodyPr wrap="square" lIns="457200" tIns="137160" rtlCol="0" anchor="ctr"/>
           <a:lstStyle/>
           <a:p>
             <a:pPr algn="ctr">
@@ -4756,10 +5029,34 @@
                 <a:tableStyleId>{5C22544A-7EE6-4342-B048-85BDC9FD1C3A}</a:tableStyleId>
               </a:tblPr>
               <a:tblGrid>
-                <a:gridCol w="1828800"/>
-                <a:gridCol w="1188720"/>
-                <a:gridCol w="1371600"/>
-                <a:gridCol w="1097280"/>
+                <a:gridCol w="1828800">
+                  <a:extLst>
+                    <a:ext uri="{9D8B030D-6E8A-4147-A177-3AD203B41FA5}">
+                      <a16:colId xmlns:a16="http://schemas.microsoft.com/office/drawing/2014/main" val="20000"/>
+                    </a:ext>
+                  </a:extLst>
+                </a:gridCol>
+                <a:gridCol w="1188720">
+                  <a:extLst>
+                    <a:ext uri="{9D8B030D-6E8A-4147-A177-3AD203B41FA5}">
+                      <a16:colId xmlns:a16="http://schemas.microsoft.com/office/drawing/2014/main" val="20001"/>
+                    </a:ext>
+                  </a:extLst>
+                </a:gridCol>
+                <a:gridCol w="1371600">
+                  <a:extLst>
+                    <a:ext uri="{9D8B030D-6E8A-4147-A177-3AD203B41FA5}">
+                      <a16:colId xmlns:a16="http://schemas.microsoft.com/office/drawing/2014/main" val="20002"/>
+                    </a:ext>
+                  </a:extLst>
+                </a:gridCol>
+                <a:gridCol w="1097280">
+                  <a:extLst>
+                    <a:ext uri="{9D8B030D-6E8A-4147-A177-3AD203B41FA5}">
+                      <a16:colId xmlns:a16="http://schemas.microsoft.com/office/drawing/2014/main" val="20003"/>
+                    </a:ext>
+                  </a:extLst>
+                </a:gridCol>
               </a:tblGrid>
               <a:tr h="571500">
                 <a:tc>
@@ -4768,7 +5065,7 @@
                     <a:lstStyle/>
                     <a:p>
                       <a:pPr algn="ctr">
-                        <a:defRPr b="1" sz="1800">
+                        <a:defRPr sz="1800" b="1">
                           <a:solidFill>
                             <a:srgbClr val="FFFFFF"/>
                           </a:solidFill>
@@ -4791,7 +5088,7 @@
                     <a:lstStyle/>
                     <a:p>
                       <a:pPr algn="ctr">
-                        <a:defRPr b="1" sz="1800">
+                        <a:defRPr sz="1800" b="1">
                           <a:solidFill>
                             <a:srgbClr val="FFFFFF"/>
                           </a:solidFill>
@@ -4814,7 +5111,7 @@
                     <a:lstStyle/>
                     <a:p>
                       <a:pPr algn="ctr">
-                        <a:defRPr b="1" sz="1800">
+                        <a:defRPr sz="1800" b="1">
                           <a:solidFill>
                             <a:srgbClr val="FFFFFF"/>
                           </a:solidFill>
@@ -4837,7 +5134,7 @@
                     <a:lstStyle/>
                     <a:p>
                       <a:pPr algn="ctr">
-                        <a:defRPr b="1" sz="1800">
+                        <a:defRPr sz="1800" b="1">
                           <a:solidFill>
                             <a:srgbClr val="FFFFFF"/>
                           </a:solidFill>
@@ -4854,6 +5151,11 @@
                     </a:solidFill>
                   </a:tcPr>
                 </a:tc>
+                <a:extLst>
+                  <a:ext uri="{0D108BD9-81ED-4DB2-BD59-A6C34878D82A}">
+                    <a16:rowId xmlns:a16="http://schemas.microsoft.com/office/drawing/2014/main" val="10000"/>
+                  </a:ext>
+                </a:extLst>
               </a:tr>
               <a:tr h="571500">
                 <a:tc>
@@ -4932,6 +5234,11 @@
                   </a:txBody>
                   <a:tcPr/>
                 </a:tc>
+                <a:extLst>
+                  <a:ext uri="{0D108BD9-81ED-4DB2-BD59-A6C34878D82A}">
+                    <a16:rowId xmlns:a16="http://schemas.microsoft.com/office/drawing/2014/main" val="10001"/>
+                  </a:ext>
+                </a:extLst>
               </a:tr>
               <a:tr h="571500">
                 <a:tc>
@@ -5010,6 +5317,11 @@
                   </a:txBody>
                   <a:tcPr/>
                 </a:tc>
+                <a:extLst>
+                  <a:ext uri="{0D108BD9-81ED-4DB2-BD59-A6C34878D82A}">
+                    <a16:rowId xmlns:a16="http://schemas.microsoft.com/office/drawing/2014/main" val="10002"/>
+                  </a:ext>
+                </a:extLst>
               </a:tr>
               <a:tr h="571500">
                 <a:tc>
@@ -5088,6 +5400,11 @@
                   </a:txBody>
                   <a:tcPr/>
                 </a:tc>
+                <a:extLst>
+                  <a:ext uri="{0D108BD9-81ED-4DB2-BD59-A6C34878D82A}">
+                    <a16:rowId xmlns:a16="http://schemas.microsoft.com/office/drawing/2014/main" val="10003"/>
+                  </a:ext>
+                </a:extLst>
               </a:tr>
             </a:tbl>
           </a:graphicData>
@@ -5155,7 +5472,7 @@
 </file>
 
 <file path=ppt/slides/slide17.xml><?xml version="1.0" encoding="utf-8"?>
-<p:sld xmlns:a="http://schemas.openxmlformats.org/drawingml/2006/main" xmlns:p="http://schemas.openxmlformats.org/presentationml/2006/main" xmlns:r="http://schemas.openxmlformats.org/officeDocument/2006/relationships">
+<p:sld xmlns:a="http://schemas.openxmlformats.org/drawingml/2006/main" xmlns:r="http://schemas.openxmlformats.org/officeDocument/2006/relationships" xmlns:p="http://schemas.openxmlformats.org/presentationml/2006/main">
   <p:cSld>
     <p:bg>
       <p:bgPr>
@@ -5171,7 +5488,14 @@
         <p:cNvGrpSpPr/>
         <p:nvPr/>
       </p:nvGrpSpPr>
-      <p:grpSpPr/>
+      <p:grpSpPr>
+        <a:xfrm>
+          <a:off x="0" y="0"/>
+          <a:ext cx="0" cy="0"/>
+          <a:chOff x="0" y="0"/>
+          <a:chExt cx="0" cy="0"/>
+        </a:xfrm>
+      </p:grpSpPr>
       <p:sp>
         <p:nvSpPr>
           <p:cNvPr id="2" name="Rectangle 1"/>
@@ -5208,7 +5532,7 @@
           </a:fontRef>
         </p:style>
         <p:txBody>
-          <a:bodyPr rtlCol="0" anchor="ctr" wrap="square" lIns="457200" tIns="137160"/>
+          <a:bodyPr wrap="square" lIns="457200" tIns="137160" rtlCol="0" anchor="ctr"/>
           <a:lstStyle/>
           <a:p>
             <a:pPr algn="ctr">
@@ -5316,7 +5640,7 @@
 </file>
 
 <file path=ppt/slides/slide18.xml><?xml version="1.0" encoding="utf-8"?>
-<p:sld xmlns:a="http://schemas.openxmlformats.org/drawingml/2006/main" xmlns:p="http://schemas.openxmlformats.org/presentationml/2006/main" xmlns:r="http://schemas.openxmlformats.org/officeDocument/2006/relationships">
+<p:sld xmlns:a="http://schemas.openxmlformats.org/drawingml/2006/main" xmlns:r="http://schemas.openxmlformats.org/officeDocument/2006/relationships" xmlns:p="http://schemas.openxmlformats.org/presentationml/2006/main">
   <p:cSld>
     <p:bg>
       <p:bgPr>
@@ -5332,7 +5656,14 @@
         <p:cNvGrpSpPr/>
         <p:nvPr/>
       </p:nvGrpSpPr>
-      <p:grpSpPr/>
+      <p:grpSpPr>
+        <a:xfrm>
+          <a:off x="0" y="0"/>
+          <a:ext cx="0" cy="0"/>
+          <a:chOff x="0" y="0"/>
+          <a:chExt cx="0" cy="0"/>
+        </a:xfrm>
+      </p:grpSpPr>
       <p:sp>
         <p:nvSpPr>
           <p:cNvPr id="2" name="Rectangle 1"/>
@@ -5369,7 +5700,7 @@
           </a:fontRef>
         </p:style>
         <p:txBody>
-          <a:bodyPr rtlCol="0" anchor="ctr" wrap="square" lIns="457200" tIns="137160"/>
+          <a:bodyPr wrap="square" lIns="457200" tIns="137160" rtlCol="0" anchor="ctr"/>
           <a:lstStyle/>
           <a:p>
             <a:pPr algn="ctr">
@@ -5507,7 +5838,7 @@
 </file>
 
 <file path=ppt/slides/slide2.xml><?xml version="1.0" encoding="utf-8"?>
-<p:sld xmlns:a="http://schemas.openxmlformats.org/drawingml/2006/main" xmlns:p="http://schemas.openxmlformats.org/presentationml/2006/main" xmlns:r="http://schemas.openxmlformats.org/officeDocument/2006/relationships">
+<p:sld xmlns:a="http://schemas.openxmlformats.org/drawingml/2006/main" xmlns:r="http://schemas.openxmlformats.org/officeDocument/2006/relationships" xmlns:p="http://schemas.openxmlformats.org/presentationml/2006/main">
   <p:cSld>
     <p:bg>
       <p:bgPr>
@@ -5523,7 +5854,14 @@
         <p:cNvGrpSpPr/>
         <p:nvPr/>
       </p:nvGrpSpPr>
-      <p:grpSpPr/>
+      <p:grpSpPr>
+        <a:xfrm>
+          <a:off x="0" y="0"/>
+          <a:ext cx="0" cy="0"/>
+          <a:chOff x="0" y="0"/>
+          <a:chExt cx="0" cy="0"/>
+        </a:xfrm>
+      </p:grpSpPr>
       <p:sp>
         <p:nvSpPr>
           <p:cNvPr id="2" name="Rectangle 1"/>
@@ -5560,7 +5898,7 @@
           </a:fontRef>
         </p:style>
         <p:txBody>
-          <a:bodyPr rtlCol="0" anchor="ctr" wrap="square" lIns="457200" tIns="137160"/>
+          <a:bodyPr wrap="square" lIns="457200" tIns="137160" rtlCol="0" anchor="ctr"/>
           <a:lstStyle/>
           <a:p>
             <a:pPr algn="ctr">
@@ -5683,7 +6021,7 @@
 </file>
 
 <file path=ppt/slides/slide3.xml><?xml version="1.0" encoding="utf-8"?>
-<p:sld xmlns:a="http://schemas.openxmlformats.org/drawingml/2006/main" xmlns:p="http://schemas.openxmlformats.org/presentationml/2006/main" xmlns:r="http://schemas.openxmlformats.org/officeDocument/2006/relationships">
+<p:sld xmlns:a="http://schemas.openxmlformats.org/drawingml/2006/main" xmlns:r="http://schemas.openxmlformats.org/officeDocument/2006/relationships" xmlns:p="http://schemas.openxmlformats.org/presentationml/2006/main">
   <p:cSld>
     <p:bg>
       <p:bgPr>
@@ -5699,7 +6037,14 @@
         <p:cNvGrpSpPr/>
         <p:nvPr/>
       </p:nvGrpSpPr>
-      <p:grpSpPr/>
+      <p:grpSpPr>
+        <a:xfrm>
+          <a:off x="0" y="0"/>
+          <a:ext cx="0" cy="0"/>
+          <a:chOff x="0" y="0"/>
+          <a:chExt cx="0" cy="0"/>
+        </a:xfrm>
+      </p:grpSpPr>
       <p:sp>
         <p:nvSpPr>
           <p:cNvPr id="2" name="Rectangle 1"/>
@@ -5736,7 +6081,7 @@
           </a:fontRef>
         </p:style>
         <p:txBody>
-          <a:bodyPr rtlCol="0" anchor="ctr" wrap="square" lIns="457200" tIns="137160"/>
+          <a:bodyPr wrap="square" lIns="457200" tIns="137160" rtlCol="0" anchor="ctr"/>
           <a:lstStyle/>
           <a:p>
             <a:pPr algn="ctr">
@@ -5829,7 +6174,7 @@
 </file>
 
 <file path=ppt/slides/slide4.xml><?xml version="1.0" encoding="utf-8"?>
-<p:sld xmlns:a="http://schemas.openxmlformats.org/drawingml/2006/main" xmlns:p="http://schemas.openxmlformats.org/presentationml/2006/main" xmlns:r="http://schemas.openxmlformats.org/officeDocument/2006/relationships">
+<p:sld xmlns:a="http://schemas.openxmlformats.org/drawingml/2006/main" xmlns:r="http://schemas.openxmlformats.org/officeDocument/2006/relationships" xmlns:p="http://schemas.openxmlformats.org/presentationml/2006/main">
   <p:cSld>
     <p:bg>
       <p:bgPr>
@@ -5845,7 +6190,14 @@
         <p:cNvGrpSpPr/>
         <p:nvPr/>
       </p:nvGrpSpPr>
-      <p:grpSpPr/>
+      <p:grpSpPr>
+        <a:xfrm>
+          <a:off x="0" y="0"/>
+          <a:ext cx="0" cy="0"/>
+          <a:chOff x="0" y="0"/>
+          <a:chExt cx="0" cy="0"/>
+        </a:xfrm>
+      </p:grpSpPr>
       <p:sp>
         <p:nvSpPr>
           <p:cNvPr id="2" name="Rectangle 1"/>
@@ -5882,7 +6234,7 @@
           </a:fontRef>
         </p:style>
         <p:txBody>
-          <a:bodyPr rtlCol="0" anchor="ctr" wrap="square" lIns="457200" tIns="137160"/>
+          <a:bodyPr wrap="square" lIns="457200" tIns="137160" rtlCol="0" anchor="ctr"/>
           <a:lstStyle/>
           <a:p>
             <a:pPr algn="ctr">
@@ -6035,7 +6387,7 @@
 </file>
 
 <file path=ppt/slides/slide5.xml><?xml version="1.0" encoding="utf-8"?>
-<p:sld xmlns:a="http://schemas.openxmlformats.org/drawingml/2006/main" xmlns:p="http://schemas.openxmlformats.org/presentationml/2006/main" xmlns:r="http://schemas.openxmlformats.org/officeDocument/2006/relationships">
+<p:sld xmlns:a="http://schemas.openxmlformats.org/drawingml/2006/main" xmlns:r="http://schemas.openxmlformats.org/officeDocument/2006/relationships" xmlns:p="http://schemas.openxmlformats.org/presentationml/2006/main">
   <p:cSld>
     <p:bg>
       <p:bgPr>
@@ -6051,7 +6403,14 @@
         <p:cNvGrpSpPr/>
         <p:nvPr/>
       </p:nvGrpSpPr>
-      <p:grpSpPr/>
+      <p:grpSpPr>
+        <a:xfrm>
+          <a:off x="0" y="0"/>
+          <a:ext cx="0" cy="0"/>
+          <a:chOff x="0" y="0"/>
+          <a:chExt cx="0" cy="0"/>
+        </a:xfrm>
+      </p:grpSpPr>
       <p:sp>
         <p:nvSpPr>
           <p:cNvPr id="2" name="Rectangle 1"/>
@@ -6088,7 +6447,7 @@
           </a:fontRef>
         </p:style>
         <p:txBody>
-          <a:bodyPr rtlCol="0" anchor="ctr" wrap="square" lIns="457200" tIns="137160"/>
+          <a:bodyPr wrap="square" lIns="457200" tIns="137160" rtlCol="0" anchor="ctr"/>
           <a:lstStyle/>
           <a:p>
             <a:pPr algn="ctr">
@@ -6211,7 +6570,7 @@
 </file>
 
 <file path=ppt/slides/slide6.xml><?xml version="1.0" encoding="utf-8"?>
-<p:sld xmlns:a="http://schemas.openxmlformats.org/drawingml/2006/main" xmlns:p="http://schemas.openxmlformats.org/presentationml/2006/main" xmlns:r="http://schemas.openxmlformats.org/officeDocument/2006/relationships">
+<p:sld xmlns:a="http://schemas.openxmlformats.org/drawingml/2006/main" xmlns:r="http://schemas.openxmlformats.org/officeDocument/2006/relationships" xmlns:p="http://schemas.openxmlformats.org/presentationml/2006/main">
   <p:cSld>
     <p:bg>
       <p:bgPr>
@@ -6227,7 +6586,14 @@
         <p:cNvGrpSpPr/>
         <p:nvPr/>
       </p:nvGrpSpPr>
-      <p:grpSpPr/>
+      <p:grpSpPr>
+        <a:xfrm>
+          <a:off x="0" y="0"/>
+          <a:ext cx="0" cy="0"/>
+          <a:chOff x="0" y="0"/>
+          <a:chExt cx="0" cy="0"/>
+        </a:xfrm>
+      </p:grpSpPr>
       <p:sp>
         <p:nvSpPr>
           <p:cNvPr id="2" name="Rectangle 1"/>
@@ -6264,7 +6630,7 @@
           </a:fontRef>
         </p:style>
         <p:txBody>
-          <a:bodyPr rtlCol="0" anchor="ctr" wrap="square" lIns="457200" tIns="137160"/>
+          <a:bodyPr wrap="square" lIns="457200" tIns="137160" rtlCol="0" anchor="ctr"/>
           <a:lstStyle/>
           <a:p>
             <a:pPr algn="ctr">
@@ -6357,7 +6723,7 @@
 </file>
 
 <file path=ppt/slides/slide7.xml><?xml version="1.0" encoding="utf-8"?>
-<p:sld xmlns:a="http://schemas.openxmlformats.org/drawingml/2006/main" xmlns:p="http://schemas.openxmlformats.org/presentationml/2006/main" xmlns:r="http://schemas.openxmlformats.org/officeDocument/2006/relationships">
+<p:sld xmlns:a="http://schemas.openxmlformats.org/drawingml/2006/main" xmlns:r="http://schemas.openxmlformats.org/officeDocument/2006/relationships" xmlns:p="http://schemas.openxmlformats.org/presentationml/2006/main">
   <p:cSld>
     <p:bg>
       <p:bgPr>
@@ -6373,7 +6739,14 @@
         <p:cNvGrpSpPr/>
         <p:nvPr/>
       </p:nvGrpSpPr>
-      <p:grpSpPr/>
+      <p:grpSpPr>
+        <a:xfrm>
+          <a:off x="0" y="0"/>
+          <a:ext cx="0" cy="0"/>
+          <a:chOff x="0" y="0"/>
+          <a:chExt cx="0" cy="0"/>
+        </a:xfrm>
+      </p:grpSpPr>
       <p:sp>
         <p:nvSpPr>
           <p:cNvPr id="2" name="Rectangle 1"/>
@@ -6410,7 +6783,7 @@
           </a:fontRef>
         </p:style>
         <p:txBody>
-          <a:bodyPr rtlCol="0" anchor="ctr" wrap="square" lIns="457200" tIns="137160"/>
+          <a:bodyPr wrap="square" lIns="457200" tIns="137160" rtlCol="0" anchor="ctr"/>
           <a:lstStyle/>
           <a:p>
             <a:pPr algn="ctr">
@@ -6518,7 +6891,7 @@
 </file>
 
 <file path=ppt/slides/slide8.xml><?xml version="1.0" encoding="utf-8"?>
-<p:sld xmlns:a="http://schemas.openxmlformats.org/drawingml/2006/main" xmlns:p="http://schemas.openxmlformats.org/presentationml/2006/main" xmlns:r="http://schemas.openxmlformats.org/officeDocument/2006/relationships">
+<p:sld xmlns:a="http://schemas.openxmlformats.org/drawingml/2006/main" xmlns:r="http://schemas.openxmlformats.org/officeDocument/2006/relationships" xmlns:p="http://schemas.openxmlformats.org/presentationml/2006/main">
   <p:cSld>
     <p:bg>
       <p:bgPr>
@@ -6534,7 +6907,14 @@
         <p:cNvGrpSpPr/>
         <p:nvPr/>
       </p:nvGrpSpPr>
-      <p:grpSpPr/>
+      <p:grpSpPr>
+        <a:xfrm>
+          <a:off x="0" y="0"/>
+          <a:ext cx="0" cy="0"/>
+          <a:chOff x="0" y="0"/>
+          <a:chExt cx="0" cy="0"/>
+        </a:xfrm>
+      </p:grpSpPr>
       <p:sp>
         <p:nvSpPr>
           <p:cNvPr id="2" name="Rectangle 1"/>
@@ -6571,7 +6951,7 @@
           </a:fontRef>
         </p:style>
         <p:txBody>
-          <a:bodyPr rtlCol="0" anchor="ctr" wrap="square" lIns="457200" tIns="137160"/>
+          <a:bodyPr wrap="square" lIns="457200" tIns="137160" rtlCol="0" anchor="ctr"/>
           <a:lstStyle/>
           <a:p>
             <a:pPr algn="ctr">
@@ -6694,7 +7074,7 @@
 </file>
 
 <file path=ppt/slides/slide9.xml><?xml version="1.0" encoding="utf-8"?>
-<p:sld xmlns:a="http://schemas.openxmlformats.org/drawingml/2006/main" xmlns:p="http://schemas.openxmlformats.org/presentationml/2006/main" xmlns:r="http://schemas.openxmlformats.org/officeDocument/2006/relationships">
+<p:sld xmlns:a="http://schemas.openxmlformats.org/drawingml/2006/main" xmlns:r="http://schemas.openxmlformats.org/officeDocument/2006/relationships" xmlns:p="http://schemas.openxmlformats.org/presentationml/2006/main">
   <p:cSld>
     <p:bg>
       <p:bgPr>
@@ -6710,7 +7090,14 @@
         <p:cNvGrpSpPr/>
         <p:nvPr/>
       </p:nvGrpSpPr>
-      <p:grpSpPr/>
+      <p:grpSpPr>
+        <a:xfrm>
+          <a:off x="0" y="0"/>
+          <a:ext cx="0" cy="0"/>
+          <a:chOff x="0" y="0"/>
+          <a:chExt cx="0" cy="0"/>
+        </a:xfrm>
+      </p:grpSpPr>
       <p:sp>
         <p:nvSpPr>
           <p:cNvPr id="2" name="Rectangle 1"/>
@@ -6747,7 +7134,7 @@
           </a:fontRef>
         </p:style>
         <p:txBody>
-          <a:bodyPr rtlCol="0" anchor="ctr" wrap="square" lIns="457200" tIns="137160"/>
+          <a:bodyPr wrap="square" lIns="457200" tIns="137160" rtlCol="0" anchor="ctr"/>
           <a:lstStyle/>
           <a:p>
             <a:pPr algn="ctr">

</xml_diff>

<commit_message>
refactor: consolidate pathfinding logic and visualization into a simplified demo script by removing auxiliary helper modules
</commit_message>
<xml_diff>
--- a/slides/slides.pptx
+++ b/slides/slides.pptx
@@ -3334,10 +3334,11 @@
               <a:t> Linh: Nguyễn Quốc Minh</a:t>
             </a:r>
             <a:r>
-              <a:rPr lang="vi-VN"/>
+              <a:rPr lang="vi-VN" dirty="0"/>
               <a:t>,</a:t>
             </a:r>
             <a:r>
+              <a:rPr dirty="0"/>
               <a:t> Võ Nguyễn Tấn Tài</a:t>
             </a:r>
           </a:p>
@@ -3474,7 +3475,7 @@
         <p:spPr>
           <a:xfrm>
             <a:off x="640080" y="1280160"/>
-            <a:ext cx="10515600" cy="5029200"/>
+            <a:ext cx="10515600" cy="1631216"/>
           </a:xfrm>
           <a:prstGeom prst="rect">
             <a:avLst/>
@@ -3498,7 +3499,64 @@
               </a:defRPr>
             </a:pPr>
             <a:r>
-              <a:t>Accuracy và ROC/AUC: dùng cho bài toán phân loại (classification).</a:t>
+              <a:rPr dirty="0"/>
+              <a:t>Accuracy </a:t>
+            </a:r>
+            <a:r>
+              <a:rPr dirty="0" err="1"/>
+              <a:t>và</a:t>
+            </a:r>
+            <a:r>
+              <a:rPr dirty="0"/>
+              <a:t> ROC/AUC: </a:t>
+            </a:r>
+            <a:r>
+              <a:rPr dirty="0" err="1"/>
+              <a:t>dùng</a:t>
+            </a:r>
+            <a:r>
+              <a:rPr dirty="0"/>
+              <a:t> </a:t>
+            </a:r>
+            <a:r>
+              <a:rPr dirty="0" err="1"/>
+              <a:t>cho</a:t>
+            </a:r>
+            <a:r>
+              <a:rPr dirty="0"/>
+              <a:t> </a:t>
+            </a:r>
+            <a:r>
+              <a:rPr dirty="0" err="1"/>
+              <a:t>bài</a:t>
+            </a:r>
+            <a:r>
+              <a:rPr dirty="0"/>
+              <a:t> </a:t>
+            </a:r>
+            <a:r>
+              <a:rPr dirty="0" err="1"/>
+              <a:t>toán</a:t>
+            </a:r>
+            <a:r>
+              <a:rPr dirty="0"/>
+              <a:t> </a:t>
+            </a:r>
+            <a:r>
+              <a:rPr dirty="0" err="1"/>
+              <a:t>phân</a:t>
+            </a:r>
+            <a:r>
+              <a:rPr dirty="0"/>
+              <a:t> </a:t>
+            </a:r>
+            <a:r>
+              <a:rPr dirty="0" err="1"/>
+              <a:t>loại</a:t>
+            </a:r>
+            <a:r>
+              <a:rPr dirty="0"/>
+              <a:t> (classification).</a:t>
             </a:r>
           </a:p>
           <a:p>
@@ -3513,7 +3571,8 @@
               </a:defRPr>
             </a:pPr>
             <a:r>
-              <a:t>Đề tài này là hồi quy (regression) vì ANN dự đoán số bước.</a:t>
+              <a:rPr dirty="0"/>
+              <a:t>Loss: Mean Squared Error (MSE) – Metric: Mean Absolute Error (MAE).</a:t>
             </a:r>
           </a:p>
           <a:p>
@@ -3528,7 +3587,72 @@
               </a:defRPr>
             </a:pPr>
             <a:r>
-              <a:t>Loss: Mean Squared Error (MSE) – Metric: Mean Absolute Error (MAE).</a:t>
+              <a:rPr dirty="0"/>
+              <a:t>MAE = 2.284 </a:t>
+            </a:r>
+            <a:r>
+              <a:rPr dirty="0" err="1"/>
+              <a:t>nghĩa</a:t>
+            </a:r>
+            <a:r>
+              <a:rPr dirty="0"/>
+              <a:t> </a:t>
+            </a:r>
+            <a:r>
+              <a:rPr dirty="0" err="1"/>
+              <a:t>là</a:t>
+            </a:r>
+            <a:r>
+              <a:rPr dirty="0"/>
+              <a:t> </a:t>
+            </a:r>
+            <a:r>
+              <a:rPr dirty="0" err="1"/>
+              <a:t>mô</a:t>
+            </a:r>
+            <a:r>
+              <a:rPr dirty="0"/>
+              <a:t> </a:t>
+            </a:r>
+            <a:r>
+              <a:rPr dirty="0" err="1"/>
+              <a:t>hình</a:t>
+            </a:r>
+            <a:r>
+              <a:rPr dirty="0"/>
+              <a:t> </a:t>
+            </a:r>
+            <a:r>
+              <a:rPr dirty="0" err="1"/>
+              <a:t>sai</a:t>
+            </a:r>
+            <a:r>
+              <a:rPr dirty="0"/>
+              <a:t> </a:t>
+            </a:r>
+            <a:r>
+              <a:rPr dirty="0" err="1"/>
+              <a:t>trung</a:t>
+            </a:r>
+            <a:r>
+              <a:rPr dirty="0"/>
+              <a:t> </a:t>
+            </a:r>
+            <a:r>
+              <a:rPr dirty="0" err="1"/>
+              <a:t>bình</a:t>
+            </a:r>
+            <a:r>
+              <a:rPr dirty="0"/>
+              <a:t> ~2.28 </a:t>
+            </a:r>
+            <a:r>
+              <a:rPr dirty="0" err="1"/>
+              <a:t>bước</a:t>
+            </a:r>
+            <a:r>
+              <a:rPr dirty="0"/>
+              <a:t>.</a:t>
             </a:r>
           </a:p>
           <a:p>
@@ -3543,22 +3667,72 @@
               </a:defRPr>
             </a:pPr>
             <a:r>
-              <a:t>MAE = 2.284 nghĩa là mô hình sai trung bình ~2.28 bước.</a:t>
-            </a:r>
-          </a:p>
-          <a:p>
-            <a:pPr>
-              <a:spcAft>
-                <a:spcPts val="800"/>
-              </a:spcAft>
-              <a:defRPr sz="2000">
-                <a:solidFill>
-                  <a:srgbClr val="2C3E50"/>
-                </a:solidFill>
-              </a:defRPr>
-            </a:pPr>
-            <a:r>
-              <a:t>Cross-validation: kiểm tra độ ổn định qua 5 lần chia dữ liệu.</a:t>
+              <a:rPr dirty="0"/>
+              <a:t>Cross-validation: </a:t>
+            </a:r>
+            <a:r>
+              <a:rPr dirty="0" err="1"/>
+              <a:t>kiểm</a:t>
+            </a:r>
+            <a:r>
+              <a:rPr dirty="0"/>
+              <a:t> </a:t>
+            </a:r>
+            <a:r>
+              <a:rPr dirty="0" err="1"/>
+              <a:t>tra</a:t>
+            </a:r>
+            <a:r>
+              <a:rPr dirty="0"/>
+              <a:t> </a:t>
+            </a:r>
+            <a:r>
+              <a:rPr dirty="0" err="1"/>
+              <a:t>độ</a:t>
+            </a:r>
+            <a:r>
+              <a:rPr dirty="0"/>
+              <a:t> </a:t>
+            </a:r>
+            <a:r>
+              <a:rPr dirty="0" err="1"/>
+              <a:t>ổn</a:t>
+            </a:r>
+            <a:r>
+              <a:rPr dirty="0"/>
+              <a:t> </a:t>
+            </a:r>
+            <a:r>
+              <a:rPr dirty="0" err="1"/>
+              <a:t>định</a:t>
+            </a:r>
+            <a:r>
+              <a:rPr dirty="0"/>
+              <a:t> qua 5 </a:t>
+            </a:r>
+            <a:r>
+              <a:rPr dirty="0" err="1"/>
+              <a:t>lần</a:t>
+            </a:r>
+            <a:r>
+              <a:rPr dirty="0"/>
+              <a:t> chia </a:t>
+            </a:r>
+            <a:r>
+              <a:rPr dirty="0" err="1"/>
+              <a:t>dữ</a:t>
+            </a:r>
+            <a:r>
+              <a:rPr dirty="0"/>
+              <a:t> </a:t>
+            </a:r>
+            <a:r>
+              <a:rPr dirty="0" err="1"/>
+              <a:t>liệu</a:t>
+            </a:r>
+            <a:r>
+              <a:rPr dirty="0"/>
+              <a:t>.</a:t>
             </a:r>
           </a:p>
         </p:txBody>
@@ -4233,7 +4407,20 @@
               </a:defRPr>
             </a:pPr>
             <a:r>
-              <a:t>Kiến trúc: Dense(64) – Dropout(0.2) – Dense(32) – Dense(16).</a:t>
+              <a:rPr dirty="0" err="1"/>
+              <a:t>Kiến</a:t>
+            </a:r>
+            <a:r>
+              <a:rPr dirty="0"/>
+              <a:t> </a:t>
+            </a:r>
+            <a:r>
+              <a:rPr dirty="0" err="1"/>
+              <a:t>trúc</a:t>
+            </a:r>
+            <a:r>
+              <a:rPr dirty="0"/>
+              <a:t>: Dense(64) – Dropout(0.2) – Dense(32) – Dense(16).</a:t>
             </a:r>
           </a:p>
           <a:p>
@@ -4248,7 +4435,28 @@
               </a:defRPr>
             </a:pPr>
             <a:r>
-              <a:t>EarlyStopping dừng ở 20 epoch.</a:t>
+              <a:rPr dirty="0" err="1"/>
+              <a:t>EarlyStopping</a:t>
+            </a:r>
+            <a:r>
+              <a:rPr dirty="0"/>
+              <a:t> </a:t>
+            </a:r>
+            <a:r>
+              <a:rPr dirty="0" err="1"/>
+              <a:t>dừng</a:t>
+            </a:r>
+            <a:r>
+              <a:rPr dirty="0"/>
+              <a:t> </a:t>
+            </a:r>
+            <a:r>
+              <a:rPr dirty="0" err="1"/>
+              <a:t>ở</a:t>
+            </a:r>
+            <a:r>
+              <a:rPr dirty="0"/>
+              <a:t> 20 epoch.</a:t>
             </a:r>
           </a:p>
           <a:p>
@@ -4263,7 +4471,24 @@
               </a:defRPr>
             </a:pPr>
             <a:r>
-              <a:t>Test MSE = 14.300, MAE = 2.284 (tốt nhất).</a:t>
+              <a:rPr dirty="0"/>
+              <a:t>Test MSE = 14.300, MAE = 2.284 (</a:t>
+            </a:r>
+            <a:r>
+              <a:rPr dirty="0" err="1"/>
+              <a:t>tốt</a:t>
+            </a:r>
+            <a:r>
+              <a:rPr dirty="0"/>
+              <a:t> </a:t>
+            </a:r>
+            <a:r>
+              <a:rPr dirty="0" err="1"/>
+              <a:t>nhất</a:t>
+            </a:r>
+            <a:r>
+              <a:rPr dirty="0"/>
+              <a:t>).</a:t>
             </a:r>
           </a:p>
           <a:p>
@@ -4278,7 +4503,40 @@
               </a:defRPr>
             </a:pPr>
             <a:r>
-              <a:t>Được tích hợp vào A* làm heuristic.</a:t>
+              <a:rPr dirty="0"/>
+              <a:t>Được </a:t>
+            </a:r>
+            <a:r>
+              <a:rPr dirty="0" err="1"/>
+              <a:t>tích</a:t>
+            </a:r>
+            <a:r>
+              <a:rPr dirty="0"/>
+              <a:t> </a:t>
+            </a:r>
+            <a:r>
+              <a:rPr dirty="0" err="1"/>
+              <a:t>hợp</a:t>
+            </a:r>
+            <a:r>
+              <a:rPr dirty="0"/>
+              <a:t> </a:t>
+            </a:r>
+            <a:r>
+              <a:rPr dirty="0" err="1"/>
+              <a:t>vào</a:t>
+            </a:r>
+            <a:r>
+              <a:rPr dirty="0"/>
+              <a:t> A* </a:t>
+            </a:r>
+            <a:r>
+              <a:rPr dirty="0" err="1"/>
+              <a:t>làm</a:t>
+            </a:r>
+            <a:r>
+              <a:rPr dirty="0"/>
+              <a:t> heuristic.</a:t>
             </a:r>
           </a:p>
         </p:txBody>
@@ -5947,7 +6205,44 @@
               </a:defRPr>
             </a:pPr>
             <a:r>
-              <a:t>Hiểu ANN học như thế nào qua forward, loss, backpropagation, epoch.</a:t>
+              <a:rPr dirty="0" err="1"/>
+              <a:t>Hiểu</a:t>
+            </a:r>
+            <a:r>
+              <a:rPr dirty="0"/>
+              <a:t> ANN </a:t>
+            </a:r>
+            <a:r>
+              <a:rPr dirty="0" err="1"/>
+              <a:t>học</a:t>
+            </a:r>
+            <a:r>
+              <a:rPr dirty="0"/>
+              <a:t> </a:t>
+            </a:r>
+            <a:r>
+              <a:rPr dirty="0" err="1"/>
+              <a:t>như</a:t>
+            </a:r>
+            <a:r>
+              <a:rPr dirty="0"/>
+              <a:t> </a:t>
+            </a:r>
+            <a:r>
+              <a:rPr dirty="0" err="1"/>
+              <a:t>thế</a:t>
+            </a:r>
+            <a:r>
+              <a:rPr dirty="0"/>
+              <a:t> </a:t>
+            </a:r>
+            <a:r>
+              <a:rPr dirty="0" err="1"/>
+              <a:t>nào</a:t>
+            </a:r>
+            <a:r>
+              <a:rPr dirty="0"/>
+              <a:t> qua forward, loss, backpropagation, epoch.</a:t>
             </a:r>
           </a:p>
           <a:p>
@@ -5962,7 +6257,52 @@
               </a:defRPr>
             </a:pPr>
             <a:r>
-              <a:t>Phân biệt vai trò của training, validation và testing set.</a:t>
+              <a:rPr dirty="0" err="1"/>
+              <a:t>Phân</a:t>
+            </a:r>
+            <a:r>
+              <a:rPr dirty="0"/>
+              <a:t> </a:t>
+            </a:r>
+            <a:r>
+              <a:rPr dirty="0" err="1"/>
+              <a:t>biệt</a:t>
+            </a:r>
+            <a:r>
+              <a:rPr dirty="0"/>
+              <a:t> </a:t>
+            </a:r>
+            <a:r>
+              <a:rPr dirty="0" err="1"/>
+              <a:t>vai</a:t>
+            </a:r>
+            <a:r>
+              <a:rPr dirty="0"/>
+              <a:t> </a:t>
+            </a:r>
+            <a:r>
+              <a:rPr dirty="0" err="1"/>
+              <a:t>trò</a:t>
+            </a:r>
+            <a:r>
+              <a:rPr dirty="0"/>
+              <a:t> </a:t>
+            </a:r>
+            <a:r>
+              <a:rPr dirty="0" err="1"/>
+              <a:t>của</a:t>
+            </a:r>
+            <a:r>
+              <a:rPr dirty="0"/>
+              <a:t> training, validation </a:t>
+            </a:r>
+            <a:r>
+              <a:rPr dirty="0" err="1"/>
+              <a:t>và</a:t>
+            </a:r>
+            <a:r>
+              <a:rPr dirty="0"/>
+              <a:t> testing set.</a:t>
             </a:r>
           </a:p>
           <a:p>
@@ -5977,7 +6317,92 @@
               </a:defRPr>
             </a:pPr>
             <a:r>
-              <a:t>Phân biệt các chỉ số đánh giá: Accuracy (phân loại) vs. MSE/MAE (hồi quy).</a:t>
+              <a:rPr dirty="0" err="1"/>
+              <a:t>Phân</a:t>
+            </a:r>
+            <a:r>
+              <a:rPr dirty="0"/>
+              <a:t> </a:t>
+            </a:r>
+            <a:r>
+              <a:rPr dirty="0" err="1"/>
+              <a:t>biệt</a:t>
+            </a:r>
+            <a:r>
+              <a:rPr dirty="0"/>
+              <a:t> </a:t>
+            </a:r>
+            <a:r>
+              <a:rPr dirty="0" err="1"/>
+              <a:t>các</a:t>
+            </a:r>
+            <a:r>
+              <a:rPr dirty="0"/>
+              <a:t> </a:t>
+            </a:r>
+            <a:r>
+              <a:rPr dirty="0" err="1"/>
+              <a:t>chỉ</a:t>
+            </a:r>
+            <a:r>
+              <a:rPr dirty="0"/>
+              <a:t> </a:t>
+            </a:r>
+            <a:r>
+              <a:rPr dirty="0" err="1"/>
+              <a:t>số</a:t>
+            </a:r>
+            <a:r>
+              <a:rPr dirty="0"/>
+              <a:t> </a:t>
+            </a:r>
+            <a:r>
+              <a:rPr dirty="0" err="1"/>
+              <a:t>đánh</a:t>
+            </a:r>
+            <a:r>
+              <a:rPr dirty="0"/>
+              <a:t> </a:t>
+            </a:r>
+            <a:r>
+              <a:rPr dirty="0" err="1"/>
+              <a:t>giá</a:t>
+            </a:r>
+            <a:r>
+              <a:rPr dirty="0"/>
+              <a:t>: Accuracy (</a:t>
+            </a:r>
+            <a:r>
+              <a:rPr dirty="0" err="1"/>
+              <a:t>phân</a:t>
+            </a:r>
+            <a:r>
+              <a:rPr dirty="0"/>
+              <a:t> </a:t>
+            </a:r>
+            <a:r>
+              <a:rPr dirty="0" err="1"/>
+              <a:t>loại</a:t>
+            </a:r>
+            <a:r>
+              <a:rPr dirty="0"/>
+              <a:t>) vs. MSE/MAE (</a:t>
+            </a:r>
+            <a:r>
+              <a:rPr dirty="0" err="1"/>
+              <a:t>hồi</a:t>
+            </a:r>
+            <a:r>
+              <a:rPr dirty="0"/>
+              <a:t> </a:t>
+            </a:r>
+            <a:r>
+              <a:rPr dirty="0" err="1"/>
+              <a:t>quy</a:t>
+            </a:r>
+            <a:r>
+              <a:rPr dirty="0"/>
+              <a:t>).</a:t>
             </a:r>
           </a:p>
           <a:p>
@@ -5992,7 +6417,56 @@
               </a:defRPr>
             </a:pPr>
             <a:r>
-              <a:t>Minh họa underfitting, overfitting và good fit bằng đồ thị train thật.</a:t>
+              <a:rPr dirty="0"/>
+              <a:t>Minh </a:t>
+            </a:r>
+            <a:r>
+              <a:rPr dirty="0" err="1"/>
+              <a:t>họa</a:t>
+            </a:r>
+            <a:r>
+              <a:rPr dirty="0"/>
+              <a:t> underfitting, overfitting </a:t>
+            </a:r>
+            <a:r>
+              <a:rPr dirty="0" err="1"/>
+              <a:t>và</a:t>
+            </a:r>
+            <a:r>
+              <a:rPr dirty="0"/>
+              <a:t> good fit </a:t>
+            </a:r>
+            <a:r>
+              <a:rPr dirty="0" err="1"/>
+              <a:t>bằng</a:t>
+            </a:r>
+            <a:r>
+              <a:rPr dirty="0"/>
+              <a:t> </a:t>
+            </a:r>
+            <a:r>
+              <a:rPr dirty="0" err="1"/>
+              <a:t>đồ</a:t>
+            </a:r>
+            <a:r>
+              <a:rPr dirty="0"/>
+              <a:t> </a:t>
+            </a:r>
+            <a:r>
+              <a:rPr dirty="0" err="1"/>
+              <a:t>thị</a:t>
+            </a:r>
+            <a:r>
+              <a:rPr dirty="0"/>
+              <a:t> train </a:t>
+            </a:r>
+            <a:r>
+              <a:rPr dirty="0" err="1"/>
+              <a:t>thật</a:t>
+            </a:r>
+            <a:r>
+              <a:rPr dirty="0"/>
+              <a:t>.</a:t>
             </a:r>
           </a:p>
           <a:p>
@@ -6007,7 +6481,76 @@
               </a:defRPr>
             </a:pPr>
             <a:r>
-              <a:t>Tích hợp ANN vào A* để thay thế heuristic Manhattan trong demo mê cung.</a:t>
+              <a:rPr dirty="0" err="1"/>
+              <a:t>Tích</a:t>
+            </a:r>
+            <a:r>
+              <a:rPr dirty="0"/>
+              <a:t> </a:t>
+            </a:r>
+            <a:r>
+              <a:rPr dirty="0" err="1"/>
+              <a:t>hợp</a:t>
+            </a:r>
+            <a:r>
+              <a:rPr dirty="0"/>
+              <a:t> ANN </a:t>
+            </a:r>
+            <a:r>
+              <a:rPr dirty="0" err="1"/>
+              <a:t>vào</a:t>
+            </a:r>
+            <a:r>
+              <a:rPr dirty="0"/>
+              <a:t> A* </a:t>
+            </a:r>
+            <a:r>
+              <a:rPr dirty="0" err="1"/>
+              <a:t>để</a:t>
+            </a:r>
+            <a:r>
+              <a:rPr dirty="0"/>
+              <a:t> </a:t>
+            </a:r>
+            <a:r>
+              <a:rPr dirty="0" err="1"/>
+              <a:t>thay</a:t>
+            </a:r>
+            <a:r>
+              <a:rPr dirty="0"/>
+              <a:t> </a:t>
+            </a:r>
+            <a:r>
+              <a:rPr dirty="0" err="1"/>
+              <a:t>thế</a:t>
+            </a:r>
+            <a:r>
+              <a:rPr dirty="0"/>
+              <a:t> heuristic Manhattan </a:t>
+            </a:r>
+            <a:r>
+              <a:rPr dirty="0" err="1"/>
+              <a:t>trong</a:t>
+            </a:r>
+            <a:r>
+              <a:rPr dirty="0"/>
+              <a:t> demo </a:t>
+            </a:r>
+            <a:r>
+              <a:rPr dirty="0" err="1"/>
+              <a:t>mê</a:t>
+            </a:r>
+            <a:r>
+              <a:rPr dirty="0"/>
+              <a:t> </a:t>
+            </a:r>
+            <a:r>
+              <a:rPr dirty="0" err="1"/>
+              <a:t>cung</a:t>
+            </a:r>
+            <a:r>
+              <a:rPr dirty="0"/>
+              <a:t>.</a:t>
             </a:r>
           </a:p>
         </p:txBody>

</xml_diff>